<commit_message>
Import exact reviewed Project Lead media revision and preserve provenance
</commit_message>
<xml_diff>
--- a/media/Control_Anchor_Video_Slides_Reviewer_Update.pptx
+++ b/media/Control_Anchor_Video_Slides_Reviewer_Update.pptx
@@ -2,22 +2,22 @@
 <file path=ppt/presentation.xml><?xml version="1.0" encoding="utf-8"?>
 <p:presentation xmlns:p="http://schemas.openxmlformats.org/presentationml/2006/main">
   <p:sldMasterIdLst>
-    <p:sldMasterId xmlns:r="http://schemas.openxmlformats.org/officeDocument/2006/relationships" id="2147483648" r:id="R0adfb497c593484d"/>
+    <p:sldMasterId xmlns:r="http://schemas.openxmlformats.org/officeDocument/2006/relationships" id="2147483648" r:id="R6a74dee4636b486e"/>
   </p:sldMasterIdLst>
   <p:notesMasterIdLst>
-    <p:notesMasterId xmlns:r="http://schemas.openxmlformats.org/officeDocument/2006/relationships" r:id="R3e5ce39a857d4b4a"/>
+    <p:notesMasterId xmlns:r="http://schemas.openxmlformats.org/officeDocument/2006/relationships" r:id="Re412211b5cb04e31"/>
   </p:notesMasterIdLst>
   <p:sldIdLst>
-    <p:sldId xmlns:r="http://schemas.openxmlformats.org/officeDocument/2006/relationships" id="256" r:id="Re932fe427a374504"/>
-    <p:sldId xmlns:r="http://schemas.openxmlformats.org/officeDocument/2006/relationships" id="257" r:id="Rb31d794869ee44ad"/>
-    <p:sldId xmlns:r="http://schemas.openxmlformats.org/officeDocument/2006/relationships" id="258" r:id="R922f55d69f104df2"/>
-    <p:sldId xmlns:r="http://schemas.openxmlformats.org/officeDocument/2006/relationships" id="259" r:id="R0f8ab95de7c74ee2"/>
-    <p:sldId xmlns:r="http://schemas.openxmlformats.org/officeDocument/2006/relationships" id="260" r:id="R26336da5a0d74422"/>
-    <p:sldId xmlns:r="http://schemas.openxmlformats.org/officeDocument/2006/relationships" id="261" r:id="Rbdf7ef13382f400f"/>
-    <p:sldId xmlns:r="http://schemas.openxmlformats.org/officeDocument/2006/relationships" id="262" r:id="Rb246548e4ec94d17"/>
-    <p:sldId xmlns:r="http://schemas.openxmlformats.org/officeDocument/2006/relationships" id="263" r:id="R7c4b7b0a37b744cb"/>
-    <p:sldId xmlns:r="http://schemas.openxmlformats.org/officeDocument/2006/relationships" id="264" r:id="R82687145884c4436"/>
-    <p:sldId xmlns:r="http://schemas.openxmlformats.org/officeDocument/2006/relationships" id="265" r:id="Rde9d05e50ec94bb7"/>
+    <p:sldId xmlns:r="http://schemas.openxmlformats.org/officeDocument/2006/relationships" id="256" r:id="R819a4634c5d049fd"/>
+    <p:sldId xmlns:r="http://schemas.openxmlformats.org/officeDocument/2006/relationships" id="257" r:id="R70fec6c4016d4ce3"/>
+    <p:sldId xmlns:r="http://schemas.openxmlformats.org/officeDocument/2006/relationships" id="258" r:id="R6b1a53f39bbb4a27"/>
+    <p:sldId xmlns:r="http://schemas.openxmlformats.org/officeDocument/2006/relationships" id="259" r:id="Rd9296a2d0b8647c2"/>
+    <p:sldId xmlns:r="http://schemas.openxmlformats.org/officeDocument/2006/relationships" id="260" r:id="Rb979a293d99b4c82"/>
+    <p:sldId xmlns:r="http://schemas.openxmlformats.org/officeDocument/2006/relationships" id="261" r:id="Rfd6b742b24c144b1"/>
+    <p:sldId xmlns:r="http://schemas.openxmlformats.org/officeDocument/2006/relationships" id="262" r:id="Ra953e2d28b32460a"/>
+    <p:sldId xmlns:r="http://schemas.openxmlformats.org/officeDocument/2006/relationships" id="263" r:id="Rb21b9e4f037142ca"/>
+    <p:sldId xmlns:r="http://schemas.openxmlformats.org/officeDocument/2006/relationships" id="264" r:id="R90a9fd218df84128"/>
+    <p:sldId xmlns:r="http://schemas.openxmlformats.org/officeDocument/2006/relationships" id="265" r:id="Rff8bf8d70cc549e1"/>
   </p:sldIdLst>
   <p:sldSz cx="18288000" cy="10287000"/>
   <p:notesSz cx="6858000" cy="9144000"/>
@@ -461,7 +461,7 @@
           </a:p>
           <a:p xmlns:a="http://schemas.openxmlformats.org/drawingml/2006/main">
             <a:r>
-              <a:t>I’m Thomas Prislac. My background includes auditing, internal controls, music and creative work. That combination has made me interested in both what people can create and how we understand what we’re relying on. I’m building Control Anchor, powered by Triadic Cognitive Systems. The idea is to help people use AI with understandable rules, useful evidence and a clear way to correct mistakes. I want it to be useful to a small business, a community organization or a family, as well as a larger institution. You shouldn’t need to become a software engineer to use it.</a:t>
+              <a:t>I’m the project lead. My background includes auditing, internal controls, music and creative work. That combination has made me interested in both what people can create and how we understand what we’re relying on. I’m building Control Anchor, powered by Triadic Cognitive Systems. The idea is to help people use AI with understandable rules, useful evidence and a clear way to correct mistakes. I want it to be useful to a small business, a community organization or a family, as well as a larger institution. You shouldn’t need to become a software engineer to use it.</a:t>
             </a:r>
           </a:p>
           <a:p xmlns:a="http://schemas.openxmlformats.org/drawingml/2006/main">
@@ -566,7 +566,7 @@
           </a:p>
           <a:p xmlns:a="http://schemas.openxmlformats.org/drawingml/2006/main">
             <a:r>
-              <a:t>I’m looking for people who can help make the first useful version work well: engineers, researchers and people with a recurring task they understand. A small-business owner could help us test whether a report actually saves review effort. A research group could examine when shared work helps and when it misleads. Families can help us understand needs through adult conversations before any child-facing pilot. My proposed model is a useful, openly inspectable core, with paid implementation and support where those services add value. I care about reducing waste and making useful tools accessible, but we have to earn those claims through what people experience. Start with the white paper or repository below. Tell me about one task you’d like to make easier, what you use today, and what would count as a better result. I’m Thomas. Thanks for taking a look at the work.</a:t>
+              <a:t>I’m looking for people who can help make the first useful version work well: engineers, researchers and people with a recurring task they understand. A small-business owner could help us test whether a report actually saves review effort. A research group could examine when shared work helps and when it misleads. Families can help us understand needs through adult conversations before any child-facing pilot. My proposed model is a useful, openly inspectable core, with paid implementation and support where those services add value. I care about reducing waste and making useful tools accessible, but we have to earn those claims through what people experience. Start with the white paper or repository below. Tell me about one task you’d like to make easier, what you use today, and what would count as a better result. I’m the project lead. Thanks for taking a look at the work.</a:t>
             </a:r>
           </a:p>
           <a:p xmlns:a="http://schemas.openxmlformats.org/drawingml/2006/main">
@@ -1510,12 +1510,21 @@
             </a:r>
           </a:p>
           <a:p xmlns:a="http://schemas.openxmlformats.org/drawingml/2006/main">
-            <a:br/>
-            <a:br/>
+            <a:r>
+              <a:t/>
+            </a:r>
+          </a:p>
+          <a:p xmlns:a="http://schemas.openxmlformats.org/drawingml/2006/main">
+            <a:r>
+              <a:t/>
+            </a:r>
+          </a:p>
+          <a:p xmlns:a="http://schemas.openxmlformats.org/drawingml/2006/main">
             <a:r>
               <a:t>Original application status source: https://github.com/pdxvoiceteacher/triadicbrain-open-alpha/blob/37583fd91ff7f0d912256c10fea89ff6896763cf/README.md</a:t>
             </a:r>
-            <a:br/>
+          </a:p>
+          <a:p xmlns:a="http://schemas.openxmlformats.org/drawingml/2006/main">
             <a:r>
               <a:t>Installation run: https://github.com/pdxvoiceteacher/triadicbrain-open-alpha/actions/runs/39161062220</a:t>
             </a:r>
@@ -3330,12 +3339,12 @@
   </p:cSld>
   <p:clrMap bg1="lt1" tx1="dk1" bg2="lt2" tx2="dk2" accent1="accent1" accent2="accent2" accent3="accent3" accent4="accent4" accent5="accent5" accent6="accent6" hlink="hlink" folHlink="folHlink"/>
   <p:sldLayoutIdLst>
-    <p:sldLayoutId xmlns:r="http://schemas.openxmlformats.org/officeDocument/2006/relationships" id="2147483649" r:id="R30ff189b94fe4eb3"/>
-    <p:sldLayoutId xmlns:r="http://schemas.openxmlformats.org/officeDocument/2006/relationships" id="2147483650" r:id="Re7e55ce3cc0c42ff"/>
-    <p:sldLayoutId xmlns:r="http://schemas.openxmlformats.org/officeDocument/2006/relationships" id="2147483651" r:id="R100fde8bc08e4f8d"/>
-    <p:sldLayoutId xmlns:r="http://schemas.openxmlformats.org/officeDocument/2006/relationships" id="2147483652" r:id="R9f4ea3e3c9db46c9"/>
-    <p:sldLayoutId xmlns:r="http://schemas.openxmlformats.org/officeDocument/2006/relationships" id="2147483653" r:id="R7fecfe78f45f41c0"/>
-    <p:sldLayoutId xmlns:r="http://schemas.openxmlformats.org/officeDocument/2006/relationships" id="2147483654" r:id="R95c94044b6984733"/>
+    <p:sldLayoutId xmlns:r="http://schemas.openxmlformats.org/officeDocument/2006/relationships" id="2147483649" r:id="R62d8eb1d2872438d"/>
+    <p:sldLayoutId xmlns:r="http://schemas.openxmlformats.org/officeDocument/2006/relationships" id="2147483650" r:id="Rd2f7cb141a3b44cf"/>
+    <p:sldLayoutId xmlns:r="http://schemas.openxmlformats.org/officeDocument/2006/relationships" id="2147483651" r:id="R2f3347c989cb48c1"/>
+    <p:sldLayoutId xmlns:r="http://schemas.openxmlformats.org/officeDocument/2006/relationships" id="2147483652" r:id="R9694c425d0054c3d"/>
+    <p:sldLayoutId xmlns:r="http://schemas.openxmlformats.org/officeDocument/2006/relationships" id="2147483653" r:id="R0ae23611413f4d05"/>
+    <p:sldLayoutId xmlns:r="http://schemas.openxmlformats.org/officeDocument/2006/relationships" id="2147483654" r:id="Rf707ecad4cba4c44"/>
   </p:sldLayoutIdLst>
   <p:txStyles>
     <p:titleStyle>
@@ -4083,7 +4092,7 @@
                 <a:ea typeface="Nimbus Sans"/>
                 <a:cs typeface="Nimbus Sans"/>
               </a:rPr>
-              <a:t>Thomas Prislac</a:t>
+              <a:t>Project Lead</a:t>
             </a:r>
           </a:p>
           <a:p xmlns:a="http://schemas.openxmlformats.org/drawingml/2006/main">
@@ -6635,7 +6644,7 @@
           <p:cNvPr id="13" name="">
             <a:extLst xmlns:a="http://schemas.openxmlformats.org/drawingml/2006/main">
               <a:ext uri="{FF2B5EF4-FFF2-40B4-BE49-F238E27FC236}">
-                <a16:creationId xmlns:a16="http://schemas.microsoft.com/office/drawing/2014/main" id="{25BBCAC2-9106-406B-A34A-6D5D10A248F3}"/>
+                <a16:creationId xmlns:a16="http://schemas.microsoft.com/office/drawing/2014/main" id="{F8B51EDE-4268-448D-96E9-F899AD46D26A}"/>
               </a:ext>
             </a:extLst>
           </p:cNvPr>
@@ -6670,7 +6679,7 @@
           <p:cNvPr id="12" name="">
             <a:extLst xmlns:a="http://schemas.openxmlformats.org/drawingml/2006/main">
               <a:ext uri="{FF2B5EF4-FFF2-40B4-BE49-F238E27FC236}">
-                <a16:creationId xmlns:a16="http://schemas.microsoft.com/office/drawing/2014/main" id="{463735A4-0492-4435-B8A0-FFF2FF2C8230}"/>
+                <a16:creationId xmlns:a16="http://schemas.microsoft.com/office/drawing/2014/main" id="{C3729149-F05A-4106-BE40-4E51840FF4AA}"/>
               </a:ext>
             </a:extLst>
           </p:cNvPr>
@@ -8335,7 +8344,7 @@
           <p:cNvPr id="13" name="">
             <a:extLst xmlns:a="http://schemas.openxmlformats.org/drawingml/2006/main">
               <a:ext uri="{FF2B5EF4-FFF2-40B4-BE49-F238E27FC236}">
-                <a16:creationId xmlns:a16="http://schemas.microsoft.com/office/drawing/2014/main" id="{20F368BC-B605-4EFA-9D4E-B1625480E29B}"/>
+                <a16:creationId xmlns:a16="http://schemas.microsoft.com/office/drawing/2014/main" id="{6318434A-74D3-4DD4-9A4C-B0884F3AC2DA}"/>
               </a:ext>
             </a:extLst>
           </p:cNvPr>
@@ -8367,7 +8376,7 @@
           <p:cNvPr id="12" name="">
             <a:extLst xmlns:a="http://schemas.openxmlformats.org/drawingml/2006/main">
               <a:ext uri="{FF2B5EF4-FFF2-40B4-BE49-F238E27FC236}">
-                <a16:creationId xmlns:a16="http://schemas.microsoft.com/office/drawing/2014/main" id="{95BFBBFE-2C1C-48EC-83F6-3E4964B420E2}"/>
+                <a16:creationId xmlns:a16="http://schemas.microsoft.com/office/drawing/2014/main" id="{51BC812C-5348-4E56-9794-7F65C00E216A}"/>
               </a:ext>
             </a:extLst>
           </p:cNvPr>

</xml_diff>